<commit_message>
docs: readable UAF earn-process-burn sequence (no spaghetti arrows)
</commit_message>
<xml_diff>
--- a/docs/decks/LedgeRX-UAF-Earn-Process-Burn-Sequence.pptx
+++ b/docs/decks/LedgeRX-UAF-Earn-Process-Burn-Sequence.pptx
@@ -1099,7 +1099,7 @@
                 <a:ea typeface="Calibri" pitchFamily="34" charset="-122"/>
                 <a:cs typeface="Calibri" pitchFamily="34" charset="-120"/>
               </a:rPr>
-              <a:t>DEMO CASE</a:t>
+              <a:t>DEMO CASE · READABLE SEQUENCE</a:t>
             </a:r>
             <a:endParaRPr lang="en-US" sz="1400" dirty="0"/>
           </a:p>
@@ -1114,7 +1114,7 @@
         <p:spPr>
           <a:xfrm>
             <a:off x="640080" y="2286000"/>
-            <a:ext cx="10972800" cy="1188720"/>
+            <a:ext cx="10972800" cy="1280160"/>
           </a:xfrm>
           <a:prstGeom prst="rect">
             <a:avLst/>
@@ -1155,7 +1155,7 @@
                 <a:ea typeface="Calibri" pitchFamily="34" charset="-122"/>
                 <a:cs typeface="Calibri" pitchFamily="34" charset="-120"/>
               </a:rPr>
-              <a:t>UA Finance CC customer transaction</a:t>
+              <a:t>UA Finance CC — HKD 500 → 5 LP</a:t>
             </a:r>
             <a:endParaRPr lang="en-US" sz="3200" dirty="0"/>
           </a:p>
@@ -1169,8 +1169,8 @@
         </p:nvSpPr>
         <p:spPr>
           <a:xfrm>
-            <a:off x="640080" y="3749040"/>
-            <a:ext cx="10972800" cy="731520"/>
+            <a:off x="640080" y="3840480"/>
+            <a:ext cx="10972800" cy="822960"/>
           </a:xfrm>
           <a:prstGeom prst="rect">
             <a:avLst/>
@@ -1186,7 +1186,7 @@
               <a:buNone/>
             </a:pPr>
             <a:r>
-              <a:rPr lang="en-US" sz="1600" dirty="0">
+              <a:rPr lang="en-US" sz="1800" dirty="0">
                 <a:solidFill>
                   <a:srgbClr val="94A3B8"/>
                 </a:solidFill>
@@ -1194,16 +1194,16 @@
                 <a:ea typeface="Calibri" pitchFamily="34" charset="-122"/>
                 <a:cs typeface="Calibri" pitchFamily="34" charset="-120"/>
               </a:rPr>
-              <a:t>HKD 500 grocery (MCC 5411) → Brain RATE 1% → 5 LP earn</a:t>
-            </a:r>
-            <a:endParaRPr lang="en-US" sz="1600" dirty="0"/>
+              <a:t>Pay → xapi → SDK → Door → Brain (500×1%) → Books (+5)</a:t>
+            </a:r>
+            <a:endParaRPr lang="en-US" sz="1800" dirty="0"/>
           </a:p>
           <a:p>
             <a:pPr indent="0" marL="0">
               <a:buNone/>
             </a:pPr>
             <a:r>
-              <a:rPr lang="en-US" sz="1600" dirty="0">
+              <a:rPr lang="en-US" sz="1800" dirty="0">
                 <a:solidFill>
                   <a:srgbClr val="94A3B8"/>
                 </a:solidFill>
@@ -1211,9 +1211,9 @@
                 <a:ea typeface="Calibri" pitchFamily="34" charset="-122"/>
                 <a:cs typeface="Calibri" pitchFamily="34" charset="-120"/>
               </a:rPr>
-              <a:t>Later redeem → 5 LP burn · SA V2–style sequence</a:t>
-            </a:r>
-            <a:endParaRPr lang="en-US" sz="1600" dirty="0"/>
+              <a:t>Later redeem → Burn (−5) → E-Coupon</a:t>
+            </a:r>
+            <a:endParaRPr lang="en-US" sz="1800" dirty="0"/>
           </a:p>
         </p:txBody>
       </p:sp>
@@ -1257,7 +1257,7 @@
             <a:avLst/>
           </a:prstGeom>
           <a:solidFill>
-            <a:srgbClr val="070B14"/>
+            <a:srgbClr val="0B1220"/>
           </a:solidFill>
           <a:ln/>
         </p:spPr>
@@ -1278,8 +1278,8 @@
         </p:blipFill>
         <p:spPr>
           <a:xfrm>
-            <a:off x="182880" y="91440"/>
-            <a:ext cx="11795760" cy="6675120"/>
+            <a:off x="1280160" y="137160"/>
+            <a:ext cx="9601200" cy="6583680"/>
           </a:xfrm>
           <a:prstGeom prst="rect">
             <a:avLst/>
@@ -1339,7 +1339,7 @@
         </p:nvSpPr>
         <p:spPr>
           <a:xfrm>
-            <a:off x="502920" y="365760"/>
+            <a:off x="548640" y="411480"/>
             <a:ext cx="10972800" cy="457200"/>
           </a:xfrm>
           <a:prstGeom prst="rect">
@@ -1356,7 +1356,7 @@
               <a:buNone/>
             </a:pPr>
             <a:r>
-              <a:rPr lang="en-US" sz="2600" b="1" dirty="0">
+              <a:rPr lang="en-US" sz="2800" b="1" dirty="0">
                 <a:solidFill>
                   <a:srgbClr val="0B1220"/>
                 </a:solidFill>
@@ -1364,9 +1364,9 @@
                 <a:ea typeface="Calibri" pitchFamily="34" charset="-122"/>
                 <a:cs typeface="Calibri" pitchFamily="34" charset="-120"/>
               </a:rPr>
-              <a:t>What the numbers mean</a:t>
-            </a:r>
-            <a:endParaRPr lang="en-US" sz="2600" dirty="0"/>
+              <a:t>One glance — the math</a:t>
+            </a:r>
+            <a:endParaRPr lang="en-US" sz="2800" dirty="0"/>
           </a:p>
         </p:txBody>
       </p:sp>
@@ -1378,12 +1378,112 @@
         </p:nvSpPr>
         <p:spPr>
           <a:xfrm>
-            <a:off x="502920" y="1143000"/>
-            <a:ext cx="2743200" cy="4846320"/>
+            <a:off x="548640" y="1188720"/>
+            <a:ext cx="11064240" cy="1828800"/>
           </a:xfrm>
           <a:prstGeom prst="roundRect">
             <a:avLst>
-              <a:gd name="adj" fmla="val 3333"/>
+              <a:gd name="adj" fmla="val 6000"/>
+            </a:avLst>
+          </a:prstGeom>
+          <a:solidFill>
+            <a:srgbClr val="0C2340"/>
+          </a:solidFill>
+          <a:ln/>
+        </p:spPr>
+      </p:sp>
+      <p:sp>
+        <p:nvSpPr>
+          <p:cNvPr id="5" name="Text 3"/>
+          <p:cNvSpPr/>
+          <p:nvPr/>
+        </p:nvSpPr>
+        <p:spPr>
+          <a:xfrm>
+            <a:off x="548640" y="1691640"/>
+            <a:ext cx="11064240" cy="640080"/>
+          </a:xfrm>
+          <a:prstGeom prst="rect">
+            <a:avLst/>
+          </a:prstGeom>
+          <a:noFill/>
+          <a:ln/>
+        </p:spPr>
+        <p:txBody>
+          <a:bodyPr wrap="square" lIns="0" tIns="0" rIns="0" bIns="0" rtlCol="0" anchor="ctr"/>
+          <a:lstStyle/>
+          <a:p>
+            <a:pPr algn="ctr" indent="0" marL="0">
+              <a:buNone/>
+            </a:pPr>
+            <a:r>
+              <a:rPr lang="en-US" sz="3600" b="1" dirty="0">
+                <a:solidFill>
+                  <a:srgbClr val="FDE68A"/>
+                </a:solidFill>
+                <a:latin typeface="Calibri" pitchFamily="34" charset="0"/>
+                <a:ea typeface="Calibri" pitchFamily="34" charset="-122"/>
+                <a:cs typeface="Calibri" pitchFamily="34" charset="-120"/>
+              </a:rPr>
+              <a:t>500 HKD  ×  1%  =  5 LP</a:t>
+            </a:r>
+            <a:endParaRPr lang="en-US" sz="3600" dirty="0"/>
+          </a:p>
+        </p:txBody>
+      </p:sp>
+      <p:sp>
+        <p:nvSpPr>
+          <p:cNvPr id="6" name="Text 4"/>
+          <p:cNvSpPr/>
+          <p:nvPr/>
+        </p:nvSpPr>
+        <p:spPr>
+          <a:xfrm>
+            <a:off x="548640" y="2377440"/>
+            <a:ext cx="11064240" cy="365760"/>
+          </a:xfrm>
+          <a:prstGeom prst="rect">
+            <a:avLst/>
+          </a:prstGeom>
+          <a:noFill/>
+          <a:ln/>
+        </p:spPr>
+        <p:txBody>
+          <a:bodyPr wrap="square" lIns="0" tIns="0" rIns="0" bIns="0" rtlCol="0" anchor="ctr"/>
+          <a:lstStyle/>
+          <a:p>
+            <a:pPr algn="ctr" indent="0" marL="0">
+              <a:buNone/>
+            </a:pPr>
+            <a:r>
+              <a:rPr lang="en-US" sz="1600" dirty="0">
+                <a:solidFill>
+                  <a:srgbClr val="94A3B8"/>
+                </a:solidFill>
+                <a:latin typeface="Calibri" pitchFamily="34" charset="0"/>
+                <a:ea typeface="Calibri" pitchFamily="34" charset="-122"/>
+                <a:cs typeface="Calibri" pitchFamily="34" charset="-120"/>
+              </a:rPr>
+              <a:t>Rule CC_EARN_MCC_5411  ·  RATE 0.01  ·  MCC 5411 grocery</a:t>
+            </a:r>
+            <a:endParaRPr lang="en-US" sz="1600" dirty="0"/>
+          </a:p>
+        </p:txBody>
+      </p:sp>
+      <p:sp>
+        <p:nvSpPr>
+          <p:cNvPr id="7" name="Shape 5"/>
+          <p:cNvSpPr/>
+          <p:nvPr/>
+        </p:nvSpPr>
+        <p:spPr>
+          <a:xfrm>
+            <a:off x="548640" y="3383280"/>
+            <a:ext cx="2148840" cy="2651760"/>
+          </a:xfrm>
+          <a:prstGeom prst="roundRect">
+            <a:avLst>
+              <a:gd name="adj" fmla="val 4255"/>
             </a:avLst>
           </a:prstGeom>
           <a:solidFill>
@@ -1401,14 +1501,14 @@
       </p:sp>
       <p:sp>
         <p:nvSpPr>
-          <p:cNvPr id="5" name="Text 3"/>
-          <p:cNvSpPr/>
-          <p:nvPr/>
-        </p:nvSpPr>
-        <p:spPr>
-          <a:xfrm>
-            <a:off x="685800" y="1417320"/>
-            <a:ext cx="2377440" cy="457200"/>
+          <p:cNvPr id="8" name="Text 6"/>
+          <p:cNvSpPr/>
+          <p:nvPr/>
+        </p:nvSpPr>
+        <p:spPr>
+          <a:xfrm>
+            <a:off x="685800" y="3657600"/>
+            <a:ext cx="1874520" cy="640080"/>
           </a:xfrm>
           <a:prstGeom prst="rect">
             <a:avLst/>
@@ -1424,7 +1524,7 @@
               <a:buNone/>
             </a:pPr>
             <a:r>
-              <a:rPr lang="en-US" sz="1600" b="1" dirty="0">
+              <a:rPr lang="en-US" sz="1500" b="1" dirty="0">
                 <a:solidFill>
                   <a:srgbClr val="0F766E"/>
                 </a:solidFill>
@@ -1432,22 +1532,22 @@
                 <a:ea typeface="Calibri" pitchFamily="34" charset="-122"/>
                 <a:cs typeface="Calibri" pitchFamily="34" charset="-120"/>
               </a:rPr>
-              <a:t>Input</a:t>
-            </a:r>
-            <a:endParaRPr lang="en-US" sz="1600" dirty="0"/>
-          </a:p>
-        </p:txBody>
-      </p:sp>
-      <p:sp>
-        <p:nvSpPr>
-          <p:cNvPr id="6" name="Text 4"/>
-          <p:cNvSpPr/>
-          <p:nvPr/>
-        </p:nvSpPr>
-        <p:spPr>
-          <a:xfrm>
-            <a:off x="685800" y="2103120"/>
-            <a:ext cx="2377440" cy="3566160"/>
+              <a:t>1–2 Come in</a:t>
+            </a:r>
+            <a:endParaRPr lang="en-US" sz="1500" dirty="0"/>
+          </a:p>
+        </p:txBody>
+      </p:sp>
+      <p:sp>
+        <p:nvSpPr>
+          <p:cNvPr id="9" name="Text 7"/>
+          <p:cNvSpPr/>
+          <p:nvPr/>
+        </p:nvSpPr>
+        <p:spPr>
+          <a:xfrm>
+            <a:off x="685800" y="4434840"/>
+            <a:ext cx="1874520" cy="1280160"/>
           </a:xfrm>
           <a:prstGeom prst="rect">
             <a:avLst/>
@@ -1471,7 +1571,7 @@
                 <a:ea typeface="Calibri" pitchFamily="34" charset="-122"/>
                 <a:cs typeface="Calibri" pitchFamily="34" charset="-120"/>
               </a:rPr>
-              <a:t>amount = 500 HKD</a:t>
+              <a:t>Customer pays</a:t>
             </a:r>
             <a:endParaRPr lang="en-US" sz="1400" dirty="0"/>
           </a:p>
@@ -1488,10 +1588,100 @@
                 <a:ea typeface="Calibri" pitchFamily="34" charset="-122"/>
                 <a:cs typeface="Calibri" pitchFamily="34" charset="-120"/>
               </a:rPr>
-              <a:t>mcc = 5411</a:t>
+              <a:t>Channel → cc-xapi</a:t>
             </a:r>
             <a:endParaRPr lang="en-US" sz="1400" dirty="0"/>
           </a:p>
+        </p:txBody>
+      </p:sp>
+      <p:sp>
+        <p:nvSpPr>
+          <p:cNvPr id="10" name="Shape 8"/>
+          <p:cNvSpPr/>
+          <p:nvPr/>
+        </p:nvSpPr>
+        <p:spPr>
+          <a:xfrm>
+            <a:off x="2834640" y="3383280"/>
+            <a:ext cx="2148840" cy="2651760"/>
+          </a:xfrm>
+          <a:prstGeom prst="roundRect">
+            <a:avLst>
+              <a:gd name="adj" fmla="val 4255"/>
+            </a:avLst>
+          </a:prstGeom>
+          <a:solidFill>
+            <a:srgbClr val="FFFFFF"/>
+          </a:solidFill>
+          <a:ln/>
+          <a:effectLst>
+            <a:outerShdw sx="100000" sy="100000" kx="0" ky="0" algn="bl" rotWithShape="0" blurRad="101600" dist="25400" dir="5400000">
+              <a:srgbClr val="0B1220">
+                <a:alpha val="6000"/>
+              </a:srgbClr>
+            </a:outerShdw>
+          </a:effectLst>
+        </p:spPr>
+      </p:sp>
+      <p:sp>
+        <p:nvSpPr>
+          <p:cNvPr id="11" name="Text 9"/>
+          <p:cNvSpPr/>
+          <p:nvPr/>
+        </p:nvSpPr>
+        <p:spPr>
+          <a:xfrm>
+            <a:off x="2971800" y="3657600"/>
+            <a:ext cx="1874520" cy="640080"/>
+          </a:xfrm>
+          <a:prstGeom prst="rect">
+            <a:avLst/>
+          </a:prstGeom>
+          <a:noFill/>
+          <a:ln/>
+        </p:spPr>
+        <p:txBody>
+          <a:bodyPr wrap="square" lIns="0" tIns="0" rIns="0" bIns="0" rtlCol="0" anchor="ctr"/>
+          <a:lstStyle/>
+          <a:p>
+            <a:pPr indent="0" marL="0">
+              <a:buNone/>
+            </a:pPr>
+            <a:r>
+              <a:rPr lang="en-US" sz="1500" b="1" dirty="0">
+                <a:solidFill>
+                  <a:srgbClr val="0F766E"/>
+                </a:solidFill>
+                <a:latin typeface="Calibri" pitchFamily="34" charset="0"/>
+                <a:ea typeface="Calibri" pitchFamily="34" charset="-122"/>
+                <a:cs typeface="Calibri" pitchFamily="34" charset="-120"/>
+              </a:rPr>
+              <a:t>3–4 Enter engine</a:t>
+            </a:r>
+            <a:endParaRPr lang="en-US" sz="1500" dirty="0"/>
+          </a:p>
+        </p:txBody>
+      </p:sp>
+      <p:sp>
+        <p:nvSpPr>
+          <p:cNvPr id="12" name="Text 10"/>
+          <p:cNvSpPr/>
+          <p:nvPr/>
+        </p:nvSpPr>
+        <p:spPr>
+          <a:xfrm>
+            <a:off x="2971800" y="4434840"/>
+            <a:ext cx="1874520" cy="1280160"/>
+          </a:xfrm>
+          <a:prstGeom prst="rect">
+            <a:avLst/>
+          </a:prstGeom>
+          <a:noFill/>
+          <a:ln/>
+        </p:spPr>
+        <p:txBody>
+          <a:bodyPr wrap="square" lIns="0" tIns="0" rIns="0" bIns="0" rtlCol="0" anchor="ctr"/>
+          <a:lstStyle/>
           <a:p>
             <a:pPr indent="0" marL="0">
               <a:buNone/>
@@ -1505,7 +1695,7 @@
                 <a:ea typeface="Calibri" pitchFamily="34" charset="-122"/>
                 <a:cs typeface="Calibri" pitchFamily="34" charset="-120"/>
               </a:rPr>
-              <a:t>eventType = PURCHASE</a:t>
+              <a:t>SDK.ingestEvent</a:t>
             </a:r>
             <a:endParaRPr lang="en-US" sz="1400" dirty="0"/>
           </a:p>
@@ -1522,10 +1712,100 @@
                 <a:ea typeface="Calibri" pitchFamily="34" charset="-122"/>
                 <a:cs typeface="Calibri" pitchFamily="34" charset="-120"/>
               </a:rPr>
-              <a:t>ownerId = 01A…</a:t>
+              <a:t>Door accepts</a:t>
             </a:r>
             <a:endParaRPr lang="en-US" sz="1400" dirty="0"/>
           </a:p>
+        </p:txBody>
+      </p:sp>
+      <p:sp>
+        <p:nvSpPr>
+          <p:cNvPr id="13" name="Shape 11"/>
+          <p:cNvSpPr/>
+          <p:nvPr/>
+        </p:nvSpPr>
+        <p:spPr>
+          <a:xfrm>
+            <a:off x="5120640" y="3383280"/>
+            <a:ext cx="2148840" cy="2651760"/>
+          </a:xfrm>
+          <a:prstGeom prst="roundRect">
+            <a:avLst>
+              <a:gd name="adj" fmla="val 4255"/>
+            </a:avLst>
+          </a:prstGeom>
+          <a:solidFill>
+            <a:srgbClr val="FFFFFF"/>
+          </a:solidFill>
+          <a:ln/>
+          <a:effectLst>
+            <a:outerShdw sx="100000" sy="100000" kx="0" ky="0" algn="bl" rotWithShape="0" blurRad="101600" dist="25400" dir="5400000">
+              <a:srgbClr val="0B1220">
+                <a:alpha val="6000"/>
+              </a:srgbClr>
+            </a:outerShdw>
+          </a:effectLst>
+        </p:spPr>
+      </p:sp>
+      <p:sp>
+        <p:nvSpPr>
+          <p:cNvPr id="14" name="Text 12"/>
+          <p:cNvSpPr/>
+          <p:nvPr/>
+        </p:nvSpPr>
+        <p:spPr>
+          <a:xfrm>
+            <a:off x="5257800" y="3657600"/>
+            <a:ext cx="1874520" cy="640080"/>
+          </a:xfrm>
+          <a:prstGeom prst="rect">
+            <a:avLst/>
+          </a:prstGeom>
+          <a:noFill/>
+          <a:ln/>
+        </p:spPr>
+        <p:txBody>
+          <a:bodyPr wrap="square" lIns="0" tIns="0" rIns="0" bIns="0" rtlCol="0" anchor="ctr"/>
+          <a:lstStyle/>
+          <a:p>
+            <a:pPr indent="0" marL="0">
+              <a:buNone/>
+            </a:pPr>
+            <a:r>
+              <a:rPr lang="en-US" sz="1500" b="1" dirty="0">
+                <a:solidFill>
+                  <a:srgbClr val="0F766E"/>
+                </a:solidFill>
+                <a:latin typeface="Calibri" pitchFamily="34" charset="0"/>
+                <a:ea typeface="Calibri" pitchFamily="34" charset="-122"/>
+                <a:cs typeface="Calibri" pitchFamily="34" charset="-120"/>
+              </a:rPr>
+              <a:t>5–7 Earn</a:t>
+            </a:r>
+            <a:endParaRPr lang="en-US" sz="1500" dirty="0"/>
+          </a:p>
+        </p:txBody>
+      </p:sp>
+      <p:sp>
+        <p:nvSpPr>
+          <p:cNvPr id="15" name="Text 13"/>
+          <p:cNvSpPr/>
+          <p:nvPr/>
+        </p:nvSpPr>
+        <p:spPr>
+          <a:xfrm>
+            <a:off x="5257800" y="4434840"/>
+            <a:ext cx="1874520" cy="1280160"/>
+          </a:xfrm>
+          <a:prstGeom prst="rect">
+            <a:avLst/>
+          </a:prstGeom>
+          <a:noFill/>
+          <a:ln/>
+        </p:spPr>
+        <p:txBody>
+          <a:bodyPr wrap="square" lIns="0" tIns="0" rIns="0" bIns="0" rtlCol="0" anchor="ctr"/>
+          <a:lstStyle/>
           <a:p>
             <a:pPr indent="0" marL="0">
               <a:buNone/>
@@ -1539,100 +1819,10 @@
                 <a:ea typeface="Calibri" pitchFamily="34" charset="-122"/>
                 <a:cs typeface="Calibri" pitchFamily="34" charset="-120"/>
               </a:rPr>
-              <a:t>eventId = txn-88</a:t>
+              <a:t>Brain calc 5 LP</a:t>
             </a:r>
             <a:endParaRPr lang="en-US" sz="1400" dirty="0"/>
           </a:p>
-        </p:txBody>
-      </p:sp>
-      <p:sp>
-        <p:nvSpPr>
-          <p:cNvPr id="7" name="Shape 5"/>
-          <p:cNvSpPr/>
-          <p:nvPr/>
-        </p:nvSpPr>
-        <p:spPr>
-          <a:xfrm>
-            <a:off x="3429000" y="1143000"/>
-            <a:ext cx="2743200" cy="4846320"/>
-          </a:xfrm>
-          <a:prstGeom prst="roundRect">
-            <a:avLst>
-              <a:gd name="adj" fmla="val 3333"/>
-            </a:avLst>
-          </a:prstGeom>
-          <a:solidFill>
-            <a:srgbClr val="FFFFFF"/>
-          </a:solidFill>
-          <a:ln/>
-          <a:effectLst>
-            <a:outerShdw sx="100000" sy="100000" kx="0" ky="0" algn="bl" rotWithShape="0" blurRad="101600" dist="25400" dir="5400000">
-              <a:srgbClr val="0B1220">
-                <a:alpha val="6000"/>
-              </a:srgbClr>
-            </a:outerShdw>
-          </a:effectLst>
-        </p:spPr>
-      </p:sp>
-      <p:sp>
-        <p:nvSpPr>
-          <p:cNvPr id="8" name="Text 6"/>
-          <p:cNvSpPr/>
-          <p:nvPr/>
-        </p:nvSpPr>
-        <p:spPr>
-          <a:xfrm>
-            <a:off x="3611880" y="1417320"/>
-            <a:ext cx="2377440" cy="457200"/>
-          </a:xfrm>
-          <a:prstGeom prst="rect">
-            <a:avLst/>
-          </a:prstGeom>
-          <a:noFill/>
-          <a:ln/>
-        </p:spPr>
-        <p:txBody>
-          <a:bodyPr wrap="square" lIns="0" tIns="0" rIns="0" bIns="0" rtlCol="0" anchor="ctr"/>
-          <a:lstStyle/>
-          <a:p>
-            <a:pPr indent="0" marL="0">
-              <a:buNone/>
-            </a:pPr>
-            <a:r>
-              <a:rPr lang="en-US" sz="1600" b="1" dirty="0">
-                <a:solidFill>
-                  <a:srgbClr val="0F766E"/>
-                </a:solidFill>
-                <a:latin typeface="Calibri" pitchFamily="34" charset="0"/>
-                <a:ea typeface="Calibri" pitchFamily="34" charset="-122"/>
-                <a:cs typeface="Calibri" pitchFamily="34" charset="-120"/>
-              </a:rPr>
-              <a:t>Brain process</a:t>
-            </a:r>
-            <a:endParaRPr lang="en-US" sz="1600" dirty="0"/>
-          </a:p>
-        </p:txBody>
-      </p:sp>
-      <p:sp>
-        <p:nvSpPr>
-          <p:cNvPr id="9" name="Text 7"/>
-          <p:cNvSpPr/>
-          <p:nvPr/>
-        </p:nvSpPr>
-        <p:spPr>
-          <a:xfrm>
-            <a:off x="3611880" y="2103120"/>
-            <a:ext cx="2377440" cy="3566160"/>
-          </a:xfrm>
-          <a:prstGeom prst="rect">
-            <a:avLst/>
-          </a:prstGeom>
-          <a:noFill/>
-          <a:ln/>
-        </p:spPr>
-        <p:txBody>
-          <a:bodyPr wrap="square" lIns="0" tIns="0" rIns="0" bIns="0" rtlCol="0" anchor="ctr"/>
-          <a:lstStyle/>
           <a:p>
             <a:pPr indent="0" marL="0">
               <a:buNone/>
@@ -1646,10 +1836,100 @@
                 <a:ea typeface="Calibri" pitchFamily="34" charset="-122"/>
                 <a:cs typeface="Calibri" pitchFamily="34" charset="-120"/>
               </a:rPr>
-              <a:t>Rule CC_EARN_MCC_5411</a:t>
+              <a:t>Books DE post</a:t>
             </a:r>
             <a:endParaRPr lang="en-US" sz="1400" dirty="0"/>
           </a:p>
+        </p:txBody>
+      </p:sp>
+      <p:sp>
+        <p:nvSpPr>
+          <p:cNvPr id="16" name="Shape 14"/>
+          <p:cNvSpPr/>
+          <p:nvPr/>
+        </p:nvSpPr>
+        <p:spPr>
+          <a:xfrm>
+            <a:off x="7406640" y="3383280"/>
+            <a:ext cx="2148840" cy="2651760"/>
+          </a:xfrm>
+          <a:prstGeom prst="roundRect">
+            <a:avLst>
+              <a:gd name="adj" fmla="val 4255"/>
+            </a:avLst>
+          </a:prstGeom>
+          <a:solidFill>
+            <a:srgbClr val="FFFFFF"/>
+          </a:solidFill>
+          <a:ln/>
+          <a:effectLst>
+            <a:outerShdw sx="100000" sy="100000" kx="0" ky="0" algn="bl" rotWithShape="0" blurRad="101600" dist="25400" dir="5400000">
+              <a:srgbClr val="0B1220">
+                <a:alpha val="6000"/>
+              </a:srgbClr>
+            </a:outerShdw>
+          </a:effectLst>
+        </p:spPr>
+      </p:sp>
+      <p:sp>
+        <p:nvSpPr>
+          <p:cNvPr id="17" name="Text 15"/>
+          <p:cNvSpPr/>
+          <p:nvPr/>
+        </p:nvSpPr>
+        <p:spPr>
+          <a:xfrm>
+            <a:off x="7543800" y="3657600"/>
+            <a:ext cx="1874520" cy="640080"/>
+          </a:xfrm>
+          <a:prstGeom prst="rect">
+            <a:avLst/>
+          </a:prstGeom>
+          <a:noFill/>
+          <a:ln/>
+        </p:spPr>
+        <p:txBody>
+          <a:bodyPr wrap="square" lIns="0" tIns="0" rIns="0" bIns="0" rtlCol="0" anchor="ctr"/>
+          <a:lstStyle/>
+          <a:p>
+            <a:pPr indent="0" marL="0">
+              <a:buNone/>
+            </a:pPr>
+            <a:r>
+              <a:rPr lang="en-US" sz="1500" b="1" dirty="0">
+                <a:solidFill>
+                  <a:srgbClr val="0F766E"/>
+                </a:solidFill>
+                <a:latin typeface="Calibri" pitchFamily="34" charset="0"/>
+                <a:ea typeface="Calibri" pitchFamily="34" charset="-122"/>
+                <a:cs typeface="Calibri" pitchFamily="34" charset="-120"/>
+              </a:rPr>
+              <a:t>8–9 See it</a:t>
+            </a:r>
+            <a:endParaRPr lang="en-US" sz="1500" dirty="0"/>
+          </a:p>
+        </p:txBody>
+      </p:sp>
+      <p:sp>
+        <p:nvSpPr>
+          <p:cNvPr id="18" name="Text 16"/>
+          <p:cNvSpPr/>
+          <p:nvPr/>
+        </p:nvSpPr>
+        <p:spPr>
+          <a:xfrm>
+            <a:off x="7543800" y="4434840"/>
+            <a:ext cx="1874520" cy="1280160"/>
+          </a:xfrm>
+          <a:prstGeom prst="rect">
+            <a:avLst/>
+          </a:prstGeom>
+          <a:noFill/>
+          <a:ln/>
+        </p:spPr>
+        <p:txBody>
+          <a:bodyPr wrap="square" lIns="0" tIns="0" rIns="0" bIns="0" rtlCol="0" anchor="ctr"/>
+          <a:lstStyle/>
           <a:p>
             <a:pPr indent="0" marL="0">
               <a:buNone/>
@@ -1663,7 +1943,7 @@
                 <a:ea typeface="Calibri" pitchFamily="34" charset="-122"/>
                 <a:cs typeface="Calibri" pitchFamily="34" charset="-120"/>
               </a:rPr>
-              <a:t>filters: type·ccy·MCC·age</a:t>
+              <a:t>Wallet +5</a:t>
             </a:r>
             <a:endParaRPr lang="en-US" sz="1400" dirty="0"/>
           </a:p>
@@ -1680,10 +1960,100 @@
                 <a:ea typeface="Calibri" pitchFamily="34" charset="-122"/>
                 <a:cs typeface="Calibri" pitchFamily="34" charset="-120"/>
               </a:rPr>
-              <a:t>formula RATE 0.01</a:t>
+              <a:t>App can notify</a:t>
             </a:r>
             <a:endParaRPr lang="en-US" sz="1400" dirty="0"/>
           </a:p>
+        </p:txBody>
+      </p:sp>
+      <p:sp>
+        <p:nvSpPr>
+          <p:cNvPr id="19" name="Shape 17"/>
+          <p:cNvSpPr/>
+          <p:nvPr/>
+        </p:nvSpPr>
+        <p:spPr>
+          <a:xfrm>
+            <a:off x="9692640" y="3383280"/>
+            <a:ext cx="2148840" cy="2651760"/>
+          </a:xfrm>
+          <a:prstGeom prst="roundRect">
+            <a:avLst>
+              <a:gd name="adj" fmla="val 4255"/>
+            </a:avLst>
+          </a:prstGeom>
+          <a:solidFill>
+            <a:srgbClr val="FFFFFF"/>
+          </a:solidFill>
+          <a:ln/>
+          <a:effectLst>
+            <a:outerShdw sx="100000" sy="100000" kx="0" ky="0" algn="bl" rotWithShape="0" blurRad="101600" dist="25400" dir="5400000">
+              <a:srgbClr val="0B1220">
+                <a:alpha val="6000"/>
+              </a:srgbClr>
+            </a:outerShdw>
+          </a:effectLst>
+        </p:spPr>
+      </p:sp>
+      <p:sp>
+        <p:nvSpPr>
+          <p:cNvPr id="20" name="Text 18"/>
+          <p:cNvSpPr/>
+          <p:nvPr/>
+        </p:nvSpPr>
+        <p:spPr>
+          <a:xfrm>
+            <a:off x="9829800" y="3657600"/>
+            <a:ext cx="1874520" cy="640080"/>
+          </a:xfrm>
+          <a:prstGeom prst="rect">
+            <a:avLst/>
+          </a:prstGeom>
+          <a:noFill/>
+          <a:ln/>
+        </p:spPr>
+        <p:txBody>
+          <a:bodyPr wrap="square" lIns="0" tIns="0" rIns="0" bIns="0" rtlCol="0" anchor="ctr"/>
+          <a:lstStyle/>
+          <a:p>
+            <a:pPr indent="0" marL="0">
+              <a:buNone/>
+            </a:pPr>
+            <a:r>
+              <a:rPr lang="en-US" sz="1500" b="1" dirty="0">
+                <a:solidFill>
+                  <a:srgbClr val="0F766E"/>
+                </a:solidFill>
+                <a:latin typeface="Calibri" pitchFamily="34" charset="0"/>
+                <a:ea typeface="Calibri" pitchFamily="34" charset="-122"/>
+                <a:cs typeface="Calibri" pitchFamily="34" charset="-120"/>
+              </a:rPr>
+              <a:t>10–12 Burn</a:t>
+            </a:r>
+            <a:endParaRPr lang="en-US" sz="1500" dirty="0"/>
+          </a:p>
+        </p:txBody>
+      </p:sp>
+      <p:sp>
+        <p:nvSpPr>
+          <p:cNvPr id="21" name="Text 19"/>
+          <p:cNvSpPr/>
+          <p:nvPr/>
+        </p:nvSpPr>
+        <p:spPr>
+          <a:xfrm>
+            <a:off x="9829800" y="4434840"/>
+            <a:ext cx="1874520" cy="1280160"/>
+          </a:xfrm>
+          <a:prstGeom prst="rect">
+            <a:avLst/>
+          </a:prstGeom>
+          <a:noFill/>
+          <a:ln/>
+        </p:spPr>
+        <p:txBody>
+          <a:bodyPr wrap="square" lIns="0" tIns="0" rIns="0" bIns="0" rtlCol="0" anchor="ctr"/>
+          <a:lstStyle/>
           <a:p>
             <a:pPr indent="0" marL="0">
               <a:buNone/>
@@ -1697,100 +2067,10 @@
                 <a:ea typeface="Calibri" pitchFamily="34" charset="-122"/>
                 <a:cs typeface="Calibri" pitchFamily="34" charset="-120"/>
               </a:rPr>
-              <a:t>first full match wins</a:t>
+              <a:t>Redeem 5 LP</a:t>
             </a:r>
             <a:endParaRPr lang="en-US" sz="1400" dirty="0"/>
           </a:p>
-        </p:txBody>
-      </p:sp>
-      <p:sp>
-        <p:nvSpPr>
-          <p:cNvPr id="10" name="Shape 8"/>
-          <p:cNvSpPr/>
-          <p:nvPr/>
-        </p:nvSpPr>
-        <p:spPr>
-          <a:xfrm>
-            <a:off x="6355080" y="1143000"/>
-            <a:ext cx="2743200" cy="4846320"/>
-          </a:xfrm>
-          <a:prstGeom prst="roundRect">
-            <a:avLst>
-              <a:gd name="adj" fmla="val 3333"/>
-            </a:avLst>
-          </a:prstGeom>
-          <a:solidFill>
-            <a:srgbClr val="FFFFFF"/>
-          </a:solidFill>
-          <a:ln/>
-          <a:effectLst>
-            <a:outerShdw sx="100000" sy="100000" kx="0" ky="0" algn="bl" rotWithShape="0" blurRad="101600" dist="25400" dir="5400000">
-              <a:srgbClr val="0B1220">
-                <a:alpha val="6000"/>
-              </a:srgbClr>
-            </a:outerShdw>
-          </a:effectLst>
-        </p:spPr>
-      </p:sp>
-      <p:sp>
-        <p:nvSpPr>
-          <p:cNvPr id="11" name="Text 9"/>
-          <p:cNvSpPr/>
-          <p:nvPr/>
-        </p:nvSpPr>
-        <p:spPr>
-          <a:xfrm>
-            <a:off x="6537960" y="1417320"/>
-            <a:ext cx="2377440" cy="457200"/>
-          </a:xfrm>
-          <a:prstGeom prst="rect">
-            <a:avLst/>
-          </a:prstGeom>
-          <a:noFill/>
-          <a:ln/>
-        </p:spPr>
-        <p:txBody>
-          <a:bodyPr wrap="square" lIns="0" tIns="0" rIns="0" bIns="0" rtlCol="0" anchor="ctr"/>
-          <a:lstStyle/>
-          <a:p>
-            <a:pPr indent="0" marL="0">
-              <a:buNone/>
-            </a:pPr>
-            <a:r>
-              <a:rPr lang="en-US" sz="1600" b="1" dirty="0">
-                <a:solidFill>
-                  <a:srgbClr val="0F766E"/>
-                </a:solidFill>
-                <a:latin typeface="Calibri" pitchFamily="34" charset="0"/>
-                <a:ea typeface="Calibri" pitchFamily="34" charset="-122"/>
-                <a:cs typeface="Calibri" pitchFamily="34" charset="-120"/>
-              </a:rPr>
-              <a:t>Earn output</a:t>
-            </a:r>
-            <a:endParaRPr lang="en-US" sz="1600" dirty="0"/>
-          </a:p>
-        </p:txBody>
-      </p:sp>
-      <p:sp>
-        <p:nvSpPr>
-          <p:cNvPr id="12" name="Text 10"/>
-          <p:cNvSpPr/>
-          <p:nvPr/>
-        </p:nvSpPr>
-        <p:spPr>
-          <a:xfrm>
-            <a:off x="6537960" y="2103120"/>
-            <a:ext cx="2377440" cy="3566160"/>
-          </a:xfrm>
-          <a:prstGeom prst="rect">
-            <a:avLst/>
-          </a:prstGeom>
-          <a:noFill/>
-          <a:ln/>
-        </p:spPr>
-        <p:txBody>
-          <a:bodyPr wrap="square" lIns="0" tIns="0" rIns="0" bIns="0" rtlCol="0" anchor="ctr"/>
-          <a:lstStyle/>
           <a:p>
             <a:pPr indent="0" marL="0">
               <a:buNone/>
@@ -1804,216 +2084,7 @@
                 <a:ea typeface="Calibri" pitchFamily="34" charset="-122"/>
                 <a:cs typeface="Calibri" pitchFamily="34" charset="-120"/>
               </a:rPr>
-              <a:t>points = 500 × 0.01 = 5 LP</a:t>
-            </a:r>
-            <a:endParaRPr lang="en-US" sz="1400" dirty="0"/>
-          </a:p>
-          <a:p>
-            <a:pPr indent="0" marL="0">
-              <a:buNone/>
-            </a:pPr>
-            <a:r>
-              <a:rPr lang="en-US" sz="1400" dirty="0">
-                <a:solidFill>
-                  <a:srgbClr val="0B1220"/>
-                </a:solidFill>
-                <a:latin typeface="Calibri" pitchFamily="34" charset="0"/>
-                <a:ea typeface="Calibri" pitchFamily="34" charset="-122"/>
-                <a:cs typeface="Calibri" pitchFamily="34" charset="-120"/>
-              </a:rPr>
-              <a:t>DE: DR PROGRAM / CR member</a:t>
-            </a:r>
-            <a:endParaRPr lang="en-US" sz="1400" dirty="0"/>
-          </a:p>
-          <a:p>
-            <a:pPr indent="0" marL="0">
-              <a:buNone/>
-            </a:pPr>
-            <a:r>
-              <a:rPr lang="en-US" sz="1400" dirty="0">
-                <a:solidFill>
-                  <a:srgbClr val="0B1220"/>
-                </a:solidFill>
-                <a:latin typeface="Calibri" pitchFamily="34" charset="0"/>
-                <a:ea typeface="Calibri" pitchFamily="34" charset="-122"/>
-                <a:cs typeface="Calibri" pitchFamily="34" charset="-120"/>
-              </a:rPr>
-              <a:t>status = EARNED</a:t>
-            </a:r>
-            <a:endParaRPr lang="en-US" sz="1400" dirty="0"/>
-          </a:p>
-          <a:p>
-            <a:pPr indent="0" marL="0">
-              <a:buNone/>
-            </a:pPr>
-            <a:r>
-              <a:rPr lang="en-US" sz="1400" dirty="0">
-                <a:solidFill>
-                  <a:srgbClr val="0B1220"/>
-                </a:solidFill>
-                <a:latin typeface="Calibri" pitchFamily="34" charset="0"/>
-                <a:ea typeface="Calibri" pitchFamily="34" charset="-122"/>
-                <a:cs typeface="Calibri" pitchFamily="34" charset="-120"/>
-              </a:rPr>
-              <a:t>idempotent eventId</a:t>
-            </a:r>
-            <a:endParaRPr lang="en-US" sz="1400" dirty="0"/>
-          </a:p>
-        </p:txBody>
-      </p:sp>
-      <p:sp>
-        <p:nvSpPr>
-          <p:cNvPr id="13" name="Shape 11"/>
-          <p:cNvSpPr/>
-          <p:nvPr/>
-        </p:nvSpPr>
-        <p:spPr>
-          <a:xfrm>
-            <a:off x="9281160" y="1143000"/>
-            <a:ext cx="2743200" cy="4846320"/>
-          </a:xfrm>
-          <a:prstGeom prst="roundRect">
-            <a:avLst>
-              <a:gd name="adj" fmla="val 3333"/>
-            </a:avLst>
-          </a:prstGeom>
-          <a:solidFill>
-            <a:srgbClr val="FFFFFF"/>
-          </a:solidFill>
-          <a:ln/>
-          <a:effectLst>
-            <a:outerShdw sx="100000" sy="100000" kx="0" ky="0" algn="bl" rotWithShape="0" blurRad="101600" dist="25400" dir="5400000">
-              <a:srgbClr val="0B1220">
-                <a:alpha val="6000"/>
-              </a:srgbClr>
-            </a:outerShdw>
-          </a:effectLst>
-        </p:spPr>
-      </p:sp>
-      <p:sp>
-        <p:nvSpPr>
-          <p:cNvPr id="14" name="Text 12"/>
-          <p:cNvSpPr/>
-          <p:nvPr/>
-        </p:nvSpPr>
-        <p:spPr>
-          <a:xfrm>
-            <a:off x="9464040" y="1417320"/>
-            <a:ext cx="2377440" cy="457200"/>
-          </a:xfrm>
-          <a:prstGeom prst="rect">
-            <a:avLst/>
-          </a:prstGeom>
-          <a:noFill/>
-          <a:ln/>
-        </p:spPr>
-        <p:txBody>
-          <a:bodyPr wrap="square" lIns="0" tIns="0" rIns="0" bIns="0" rtlCol="0" anchor="ctr"/>
-          <a:lstStyle/>
-          <a:p>
-            <a:pPr indent="0" marL="0">
-              <a:buNone/>
-            </a:pPr>
-            <a:r>
-              <a:rPr lang="en-US" sz="1600" b="1" dirty="0">
-                <a:solidFill>
-                  <a:srgbClr val="0F766E"/>
-                </a:solidFill>
-                <a:latin typeface="Calibri" pitchFamily="34" charset="0"/>
-                <a:ea typeface="Calibri" pitchFamily="34" charset="-122"/>
-                <a:cs typeface="Calibri" pitchFamily="34" charset="-120"/>
-              </a:rPr>
-              <a:t>Later burn</a:t>
-            </a:r>
-            <a:endParaRPr lang="en-US" sz="1600" dirty="0"/>
-          </a:p>
-        </p:txBody>
-      </p:sp>
-      <p:sp>
-        <p:nvSpPr>
-          <p:cNvPr id="15" name="Text 13"/>
-          <p:cNvSpPr/>
-          <p:nvPr/>
-        </p:nvSpPr>
-        <p:spPr>
-          <a:xfrm>
-            <a:off x="9464040" y="2103120"/>
-            <a:ext cx="2377440" cy="3566160"/>
-          </a:xfrm>
-          <a:prstGeom prst="rect">
-            <a:avLst/>
-          </a:prstGeom>
-          <a:noFill/>
-          <a:ln/>
-        </p:spPr>
-        <p:txBody>
-          <a:bodyPr wrap="square" lIns="0" tIns="0" rIns="0" bIns="0" rtlCol="0" anchor="ctr"/>
-          <a:lstStyle/>
-          <a:p>
-            <a:pPr indent="0" marL="0">
-              <a:buNone/>
-            </a:pPr>
-            <a:r>
-              <a:rPr lang="en-US" sz="1400" dirty="0">
-                <a:solidFill>
-                  <a:srgbClr val="0B1220"/>
-                </a:solidFill>
-                <a:latin typeface="Calibri" pitchFamily="34" charset="0"/>
-                <a:ea typeface="Calibri" pitchFamily="34" charset="-122"/>
-                <a:cs typeface="Calibri" pitchFamily="34" charset="-120"/>
-              </a:rPr>
-              <a:t>eventType REDEEM</a:t>
-            </a:r>
-            <a:endParaRPr lang="en-US" sz="1400" dirty="0"/>
-          </a:p>
-          <a:p>
-            <a:pPr indent="0" marL="0">
-              <a:buNone/>
-            </a:pPr>
-            <a:r>
-              <a:rPr lang="en-US" sz="1400" dirty="0">
-                <a:solidFill>
-                  <a:srgbClr val="0B1220"/>
-                </a:solidFill>
-                <a:latin typeface="Calibri" pitchFamily="34" charset="0"/>
-                <a:ea typeface="Calibri" pitchFamily="34" charset="-122"/>
-                <a:cs typeface="Calibri" pitchFamily="34" charset="-120"/>
-              </a:rPr>
-              <a:t>AMT = 5 LP</a:t>
-            </a:r>
-            <a:endParaRPr lang="en-US" sz="1400" dirty="0"/>
-          </a:p>
-          <a:p>
-            <a:pPr indent="0" marL="0">
-              <a:buNone/>
-            </a:pPr>
-            <a:r>
-              <a:rPr lang="en-US" sz="1400" dirty="0">
-                <a:solidFill>
-                  <a:srgbClr val="0B1220"/>
-                </a:solidFill>
-                <a:latin typeface="Calibri" pitchFamily="34" charset="0"/>
-                <a:ea typeface="Calibri" pitchFamily="34" charset="-122"/>
-                <a:cs typeface="Calibri" pitchFamily="34" charset="-120"/>
-              </a:rPr>
-              <a:t>DR member / CR PROGRAM</a:t>
-            </a:r>
-            <a:endParaRPr lang="en-US" sz="1400" dirty="0"/>
-          </a:p>
-          <a:p>
-            <a:pPr indent="0" marL="0">
-              <a:buNone/>
-            </a:pPr>
-            <a:r>
-              <a:rPr lang="en-US" sz="1400" dirty="0">
-                <a:solidFill>
-                  <a:srgbClr val="0B1220"/>
-                </a:solidFill>
-                <a:latin typeface="Calibri" pitchFamily="34" charset="0"/>
-                <a:ea typeface="Calibri" pitchFamily="34" charset="-122"/>
-                <a:cs typeface="Calibri" pitchFamily="34" charset="-120"/>
-              </a:rPr>
-              <a:t>+ E-Coupon fulfil (out)</a:t>
+              <a:t>Coupon fulfil</a:t>
             </a:r>
             <a:endParaRPr lang="en-US" sz="1400" dirty="0"/>
           </a:p>

</xml_diff>